<commit_message>
MoVieS NVIDIA visuals from final_benchmark; teaser deck MoVieS cell and 'novel views and timestamps' wording; video chapter title re-rendered
Co-Authored-By: Claude Fable 5.1 <noreply@anthropic.com>
</commit_message>
<xml_diff>
--- a/tools/teaser_ppt/teaser.pptx
+++ b/tools/teaser_ppt/teaser.pptx
@@ -3177,7 +3177,7 @@
                 </a:solidFill>
                 <a:latin typeface="Google Sans"/>
               </a:rPr>
-              <a:t>Any view, any time, from one monocular video</a:t>
+              <a:t>Novel views and timestamps from one monocular video</a:t>
             </a:r>
           </a:p>
         </p:txBody>
@@ -5243,7 +5243,7 @@
                 </a:solidFill>
                 <a:latin typeface="Google Sans"/>
               </a:rPr>
-              <a:t>ghosting</a:t>
+              <a:t>tearing</a:t>
             </a:r>
           </a:p>
         </p:txBody>

</xml_diff>